<commit_message>
Set phase 0 to 3 minutes and phase 1 to 7, and ease the painpoint type.
</commit_message>
<xml_diff>
--- a/docs/Wealth-Symposium-Facilitator-Guide.pptx
+++ b/docs/Wealth-Symposium-Facilitator-Guide.pptx
@@ -5138,7 +5138,7 @@
                 <a:ea typeface="Calibri"/>
                 <a:cs typeface="Calibri"/>
               </a:rPr>
-              <a:t>5:00</a:t>
+              <a:t>3:00</a:t>
             </a:r>
           </a:p>
         </p:txBody>
@@ -5183,7 +5183,7 @@
                 <a:ea typeface="Calibri"/>
                 <a:cs typeface="Calibri"/>
               </a:rPr>
-              <a:t>Minute 0 to 5</a:t>
+              <a:t>Minute 0 to 3</a:t>
             </a:r>
           </a:p>
         </p:txBody>
@@ -5450,7 +5450,7 @@
                 <a:ea typeface="Calibri"/>
                 <a:cs typeface="Calibri"/>
               </a:rPr>
-              <a:t>5:00</a:t>
+              <a:t>7:00</a:t>
             </a:r>
           </a:p>
         </p:txBody>
@@ -5539,7 +5539,7 @@
                 <a:ea typeface="Calibri"/>
                 <a:cs typeface="Calibri"/>
               </a:rPr>
-              <a:t>Minute 5 to 10</a:t>
+              <a:t>Minute 3 to 10</a:t>
             </a:r>
           </a:p>
         </p:txBody>
@@ -8490,7 +8490,7 @@
                 <a:ea typeface="Calibri"/>
                 <a:cs typeface="Calibri"/>
               </a:rPr>
-              <a:t>5 minutes</a:t>
+              <a:t>3 minutes</a:t>
             </a:r>
           </a:p>
         </p:txBody>
@@ -8717,7 +8717,7 @@
                 <a:ea typeface="Calibri"/>
                 <a:cs typeface="Calibri"/>
               </a:rPr>
-              <a:t>5 minutes</a:t>
+              <a:t>7 minutes</a:t>
             </a:r>
           </a:p>
         </p:txBody>

</xml_diff>